<commit_message>
fix(orchestrator): resolve table column parsing and finalize media deliverables for labs 35-40
</commit_message>
<xml_diff>
--- a/labs/35-websocket-and-sse/result/linkedin/lab-35-websocket-and-sse-carousel.pptx
+++ b/labs/35-websocket-and-sse/result/linkedin/lab-35-websocket-and-sse-carousel.pptx
@@ -10224,7 +10224,7 @@
         </p:nvGraphicFramePr>
         <p:xfrm>
           <a:off x="731520" y="1828800"/>
-          <a:ext cx="5120640" cy="3657600"/>
+          <a:ext cx="5120640" cy="3291840"/>
         </p:xfrm>
         <a:graphic>
           <a:graphicData uri="http://schemas.openxmlformats.org/drawingml/2006/table">
@@ -10237,14 +10237,14 @@
                 <a:gridCol w="1706880"/>
                 <a:gridCol w="1706880"/>
               </a:tblGrid>
-              <a:tr h="457200">
+              <a:tr h="411480">
                 <a:tc>
                   <a:txBody>
                     <a:bodyPr/>
                     <a:lstStyle/>
                     <a:p>
                       <a:pPr>
-                        <a:defRPr b="1" sz="1100">
+                        <a:defRPr b="1" sz="1000">
                           <a:solidFill>
                             <a:srgbClr val="FFFFFF"/>
                           </a:solidFill>
@@ -10267,7 +10267,7 @@
                     <a:lstStyle/>
                     <a:p>
                       <a:pPr>
-                        <a:defRPr b="1" sz="1100">
+                        <a:defRPr b="1" sz="1000">
                           <a:solidFill>
                             <a:srgbClr val="FFFFFF"/>
                           </a:solidFill>
@@ -10290,7 +10290,7 @@
                     <a:lstStyle/>
                     <a:p>
                       <a:pPr>
-                        <a:defRPr b="1" sz="1100">
+                        <a:defRPr b="1" sz="1000">
                           <a:solidFill>
                             <a:srgbClr val="FFFFFF"/>
                           </a:solidFill>
@@ -10308,14 +10308,14 @@
                   </a:tcPr>
                 </a:tc>
               </a:tr>
-              <a:tr h="457200">
+              <a:tr h="411480">
                 <a:tc>
                   <a:txBody>
                     <a:bodyPr/>
                     <a:lstStyle/>
                     <a:p>
                       <a:pPr>
-                        <a:defRPr sz="1000">
+                        <a:defRPr sz="900">
                           <a:solidFill>
                             <a:srgbClr val="0B1B2D"/>
                           </a:solidFill>
@@ -10338,7 +10338,7 @@
                     <a:lstStyle/>
                     <a:p>
                       <a:pPr>
-                        <a:defRPr sz="1000">
+                        <a:defRPr sz="900">
                           <a:solidFill>
                             <a:srgbClr val="0B1B2D"/>
                           </a:solidFill>
@@ -10361,7 +10361,7 @@
                     <a:lstStyle/>
                     <a:p>
                       <a:pPr>
-                        <a:defRPr sz="1000">
+                        <a:defRPr sz="900">
                           <a:solidFill>
                             <a:srgbClr val="0B1B2D"/>
                           </a:solidFill>
@@ -10379,14 +10379,14 @@
                   </a:tcPr>
                 </a:tc>
               </a:tr>
-              <a:tr h="457200">
+              <a:tr h="411480">
                 <a:tc>
                   <a:txBody>
                     <a:bodyPr/>
                     <a:lstStyle/>
                     <a:p>
                       <a:pPr>
-                        <a:defRPr sz="1000">
+                        <a:defRPr sz="900">
                           <a:solidFill>
                             <a:srgbClr val="0B1B2D"/>
                           </a:solidFill>
@@ -10409,7 +10409,7 @@
                     <a:lstStyle/>
                     <a:p>
                       <a:pPr>
-                        <a:defRPr sz="1000">
+                        <a:defRPr sz="900">
                           <a:solidFill>
                             <a:srgbClr val="0B1B2D"/>
                           </a:solidFill>
@@ -10432,7 +10432,7 @@
                     <a:lstStyle/>
                     <a:p>
                       <a:pPr>
-                        <a:defRPr sz="1000">
+                        <a:defRPr sz="900">
                           <a:solidFill>
                             <a:srgbClr val="0B1B2D"/>
                           </a:solidFill>
@@ -10450,14 +10450,14 @@
                   </a:tcPr>
                 </a:tc>
               </a:tr>
-              <a:tr h="457200">
+              <a:tr h="411480">
                 <a:tc>
                   <a:txBody>
                     <a:bodyPr/>
                     <a:lstStyle/>
                     <a:p>
                       <a:pPr>
-                        <a:defRPr sz="1000">
+                        <a:defRPr sz="900">
                           <a:solidFill>
                             <a:srgbClr val="0B1B2D"/>
                           </a:solidFill>
@@ -10480,7 +10480,7 @@
                     <a:lstStyle/>
                     <a:p>
                       <a:pPr>
-                        <a:defRPr sz="1000">
+                        <a:defRPr sz="900">
                           <a:solidFill>
                             <a:srgbClr val="0B1B2D"/>
                           </a:solidFill>
@@ -10503,7 +10503,7 @@
                     <a:lstStyle/>
                     <a:p>
                       <a:pPr>
-                        <a:defRPr sz="1000">
+                        <a:defRPr sz="900">
                           <a:solidFill>
                             <a:srgbClr val="0B1B2D"/>
                           </a:solidFill>
@@ -10521,14 +10521,14 @@
                   </a:tcPr>
                 </a:tc>
               </a:tr>
-              <a:tr h="457200">
+              <a:tr h="411480">
                 <a:tc>
                   <a:txBody>
                     <a:bodyPr/>
                     <a:lstStyle/>
                     <a:p>
                       <a:pPr>
-                        <a:defRPr sz="1000">
+                        <a:defRPr sz="900">
                           <a:solidFill>
                             <a:srgbClr val="0B1B2D"/>
                           </a:solidFill>
@@ -10551,7 +10551,7 @@
                     <a:lstStyle/>
                     <a:p>
                       <a:pPr>
-                        <a:defRPr sz="1000">
+                        <a:defRPr sz="900">
                           <a:solidFill>
                             <a:srgbClr val="0B1B2D"/>
                           </a:solidFill>
@@ -10574,7 +10574,7 @@
                     <a:lstStyle/>
                     <a:p>
                       <a:pPr>
-                        <a:defRPr sz="1000">
+                        <a:defRPr sz="900">
                           <a:solidFill>
                             <a:srgbClr val="0B1B2D"/>
                           </a:solidFill>
@@ -10592,14 +10592,14 @@
                   </a:tcPr>
                 </a:tc>
               </a:tr>
-              <a:tr h="457200">
+              <a:tr h="411480">
                 <a:tc>
                   <a:txBody>
                     <a:bodyPr/>
                     <a:lstStyle/>
                     <a:p>
                       <a:pPr>
-                        <a:defRPr sz="1000">
+                        <a:defRPr sz="900">
                           <a:solidFill>
                             <a:srgbClr val="0B1B2D"/>
                           </a:solidFill>
@@ -10622,7 +10622,7 @@
                     <a:lstStyle/>
                     <a:p>
                       <a:pPr>
-                        <a:defRPr sz="1000">
+                        <a:defRPr sz="900">
                           <a:solidFill>
                             <a:srgbClr val="0B1B2D"/>
                           </a:solidFill>
@@ -10645,7 +10645,7 @@
                     <a:lstStyle/>
                     <a:p>
                       <a:pPr>
-                        <a:defRPr sz="1000">
+                        <a:defRPr sz="900">
                           <a:solidFill>
                             <a:srgbClr val="0B1B2D"/>
                           </a:solidFill>
@@ -10663,14 +10663,14 @@
                   </a:tcPr>
                 </a:tc>
               </a:tr>
-              <a:tr h="457200">
+              <a:tr h="411480">
                 <a:tc>
                   <a:txBody>
                     <a:bodyPr/>
                     <a:lstStyle/>
                     <a:p>
                       <a:pPr>
-                        <a:defRPr sz="1000">
+                        <a:defRPr sz="900">
                           <a:solidFill>
                             <a:srgbClr val="0B1B2D"/>
                           </a:solidFill>
@@ -10693,7 +10693,7 @@
                     <a:lstStyle/>
                     <a:p>
                       <a:pPr>
-                        <a:defRPr sz="1000">
+                        <a:defRPr sz="900">
                           <a:solidFill>
                             <a:srgbClr val="0B1B2D"/>
                           </a:solidFill>
@@ -10716,7 +10716,7 @@
                     <a:lstStyle/>
                     <a:p>
                       <a:pPr>
-                        <a:defRPr sz="1000">
+                        <a:defRPr sz="900">
                           <a:solidFill>
                             <a:srgbClr val="0B1B2D"/>
                           </a:solidFill>
@@ -10734,14 +10734,14 @@
                   </a:tcPr>
                 </a:tc>
               </a:tr>
-              <a:tr h="457200">
+              <a:tr h="411480">
                 <a:tc>
                   <a:txBody>
                     <a:bodyPr/>
                     <a:lstStyle/>
                     <a:p>
                       <a:pPr>
-                        <a:defRPr sz="1000">
+                        <a:defRPr sz="900">
                           <a:solidFill>
                             <a:srgbClr val="0B1B2D"/>
                           </a:solidFill>
@@ -10764,7 +10764,7 @@
                     <a:lstStyle/>
                     <a:p>
                       <a:pPr>
-                        <a:defRPr sz="1000">
+                        <a:defRPr sz="900">
                           <a:solidFill>
                             <a:srgbClr val="0B1B2D"/>
                           </a:solidFill>
@@ -10787,7 +10787,7 @@
                     <a:lstStyle/>
                     <a:p>
                       <a:pPr>
-                        <a:defRPr sz="1000">
+                        <a:defRPr sz="900">
                           <a:solidFill>
                             <a:srgbClr val="0B1B2D"/>
                           </a:solidFill>

</xml_diff>